<commit_message>
Organize course materials and align domain guidance
Add a repository starting point, clarify the two practice exams, and align Day 1 and Day 4 deck domain labels and weights with the current syllabus.

Co-authored-by: Copilot <223556219+Copilot@users.noreply.github.com>
</commit_message>
<xml_diff>
--- a/CCAR-F_Bootcamp_Resources_Aug_2026_Current/Claude_Cert_Day1_Agentic_Architecture.pptx
+++ b/CCAR-F_Bootcamp_Resources_Aug_2026_Current/Claude_Cert_Day1_Agentic_Architecture.pptx
@@ -32057,7 +32057,7 @@
                           <a:ea typeface="Calibri" pitchFamily="34" charset="-122"/>
                           <a:cs typeface="Calibri" pitchFamily="34" charset="-120"/>
                         </a:rPr>
-                        <a:t>Implementation &amp; Tooling</a:t>
+                        <a:t>Tool Design &amp; MCP Integration</a:t>
                       </a:r>
                       <a:endParaRPr lang="en-US" sz="1300" dirty="0">
                         <a:latin typeface="Calibri" charset="0"/>
@@ -32122,7 +32122,7 @@
                           <a:ea typeface="Calibri" pitchFamily="34" charset="-122"/>
                           <a:cs typeface="Calibri" pitchFamily="34" charset="-120"/>
                         </a:rPr>
-                        <a:t>—</a:t>
+                        <a:t>18%</a:t>
                       </a:r>
                       <a:endParaRPr lang="en-US" sz="1300" dirty="0">
                         <a:latin typeface="Calibri" charset="0"/>
@@ -32324,7 +32324,7 @@
                           <a:ea typeface="Calibri" pitchFamily="34" charset="-122"/>
                           <a:cs typeface="Calibri" pitchFamily="34" charset="-120"/>
                         </a:rPr>
-                        <a:t>Claude Code &amp; MCP Integration</a:t>
+                        <a:t>Claude Code Configuration &amp; Workflows</a:t>
                       </a:r>
                       <a:endParaRPr lang="en-US" sz="1300" dirty="0">
                         <a:latin typeface="Calibri" charset="0"/>
@@ -32389,7 +32389,7 @@
                           <a:ea typeface="Calibri" pitchFamily="34" charset="-122"/>
                           <a:cs typeface="Calibri" pitchFamily="34" charset="-120"/>
                         </a:rPr>
-                        <a:t>—</a:t>
+                        <a:t>20%</a:t>
                       </a:r>
                       <a:endParaRPr lang="en-US" sz="1300" dirty="0">
                         <a:latin typeface="Calibri" charset="0"/>
@@ -32591,7 +32591,7 @@
                           <a:ea typeface="Calibri" pitchFamily="34" charset="-122"/>
                           <a:cs typeface="Calibri" pitchFamily="34" charset="-120"/>
                         </a:rPr>
-                        <a:t>Evaluation &amp; Safety</a:t>
+                        <a:t>Prompt Engineering &amp; Structured Output</a:t>
                       </a:r>
                       <a:endParaRPr lang="en-US" sz="1300" dirty="0">
                         <a:latin typeface="Calibri" charset="0"/>
@@ -32656,7 +32656,7 @@
                           <a:ea typeface="Calibri" pitchFamily="34" charset="-122"/>
                           <a:cs typeface="Calibri" pitchFamily="34" charset="-120"/>
                         </a:rPr>
-                        <a:t>—</a:t>
+                        <a:t>20%</a:t>
                       </a:r>
                       <a:endParaRPr lang="en-US" sz="1300" dirty="0">
                         <a:latin typeface="Calibri" charset="0"/>
@@ -32858,7 +32858,7 @@
                           <a:ea typeface="Calibri" pitchFamily="34" charset="-122"/>
                           <a:cs typeface="Calibri" pitchFamily="34" charset="-120"/>
                         </a:rPr>
-                        <a:t>Deployment, Governance &amp; Assessment</a:t>
+                        <a:t>Context Management &amp; Reliability</a:t>
                       </a:r>
                       <a:endParaRPr lang="en-US" sz="1300" dirty="0">
                         <a:latin typeface="Calibri" charset="0"/>
@@ -32923,7 +32923,7 @@
                           <a:ea typeface="Calibri" pitchFamily="34" charset="-122"/>
                           <a:cs typeface="Calibri" pitchFamily="34" charset="-120"/>
                         </a:rPr>
-                        <a:t>—</a:t>
+                        <a:t>15%</a:t>
                       </a:r>
                       <a:endParaRPr lang="en-US" sz="1300" dirty="0">
                         <a:latin typeface="Calibri" charset="0"/>
@@ -33152,7 +33152,7 @@
                 <a:ea typeface="Calibri" pitchFamily="34" charset="-122"/>
                 <a:cs typeface="Calibri" pitchFamily="34" charset="-120"/>
               </a:rPr>
-              <a:t>Exact percentages for Domains 2–5 will be confirmed by your program coordinator. Use this table to plan your after-hours revision time — spend more time on domains with a higher weight.</a:t>
+              <a:t>The current syllabus lists these domain weights. Confirm the latest official exam guide before each cohort because domain weights can change.</a:t>
             </a:r>
             <a:endParaRPr lang="en-US" sz="1250" dirty="0"/>
           </a:p>

</xml_diff>